<commit_message>
Round 1 deck: team SYNTAX TERROR (TAN) with members and roles; report byline
Co-Authored-By: Claude Opus 5.5 <noreply@anthropic.com>
Claude-Session: https://claude.ai/code/session_01SCrYvEnNEBd2cWGPuTq3si
</commit_message>
<xml_diff>
--- a/commodity/presentation/round1/Parity_SyntaxTerror_Round1.pptx
+++ b/commodity/presentation/round1/Parity_SyntaxTerror_Round1.pptx
@@ -751,7 +751,7 @@
           <a:lstStyle/>
           <a:p>
             <a:r>
-              <a:t>Team SyntaxTerror, project Parity, for Problem 03. Replace the red placeholders with each member's name and role before submitting.</a:t>
+              <a:t>Team SYNTAX TERROR (TAN): Nikhil Kumar leads and built the data pipeline, strategies and dashboard; Sai Ganesh on market research and the pitch; Ishaan Chhabra on testing and documentation.</a:t>
             </a:r>
           </a:p>
         </p:txBody>
@@ -11205,7 +11205,7 @@
                 </a:solidFill>
                 <a:latin typeface="Montserrat"/>
               </a:rPr>
-              <a:t>SyntaxTerror</a:t>
+              <a:t>SYNTAX TERROR (TAN)</a:t>
             </a:r>
           </a:p>
           <a:p>
@@ -11243,7 +11243,7 @@
         <p:spPr>
           <a:xfrm>
             <a:off x="9326880" y="4754880"/>
-            <a:ext cx="8138160" cy="4846320"/>
+            <a:ext cx="8138160" cy="4572000"/>
           </a:xfrm>
           <a:prstGeom prst="roundRect">
             <a:avLst>
@@ -11339,7 +11339,7 @@
           <a:p>
             <a:pPr algn="l"/>
             <a:r>
-              <a:rPr sz="2200" b="1" i="0">
+              <a:rPr sz="2400" b="1" i="0">
                 <a:solidFill>
                   <a:srgbClr val="1D1D1F"/>
                 </a:solidFill>
@@ -11358,8 +11358,8 @@
         </p:nvSpPr>
         <p:spPr>
           <a:xfrm>
-            <a:off x="9692640" y="5943600"/>
-            <a:ext cx="7406640" cy="365760"/>
+            <a:off x="9692640" y="5989320"/>
+            <a:ext cx="7406640" cy="640080"/>
           </a:xfrm>
           <a:prstGeom prst="rect">
             <a:avLst/>
@@ -11376,11 +11376,11 @@
             <a:r>
               <a:rPr sz="1700" b="0" i="0">
                 <a:solidFill>
-                  <a:srgbClr val="B43A2E"/>
+                  <a:srgbClr val="55555A"/>
                 </a:solidFill>
                 <a:latin typeface="Calibri"/>
               </a:rPr>
-              <a:t>ROLE (fill in)</a:t>
+              <a:t>Team lead · data pipeline, strategy research and backtests, dashboard</a:t>
             </a:r>
           </a:p>
         </p:txBody>
@@ -11393,7 +11393,7 @@
         </p:nvSpPr>
         <p:spPr>
           <a:xfrm>
-            <a:off x="9692640" y="6519672"/>
+            <a:off x="9692640" y="6739128"/>
             <a:ext cx="7406640" cy="411480"/>
           </a:xfrm>
           <a:prstGeom prst="rect">
@@ -11409,13 +11409,13 @@
           <a:p>
             <a:pPr algn="l"/>
             <a:r>
-              <a:rPr sz="2200" b="1" i="0">
-                <a:solidFill>
-                  <a:srgbClr val="B43A2E"/>
+              <a:rPr sz="2400" b="1" i="0">
+                <a:solidFill>
+                  <a:srgbClr val="1D1D1F"/>
                 </a:solidFill>
                 <a:latin typeface="Calibri"/>
               </a:rPr>
-              <a:t>MEMBER 2 NAME (fill in)</a:t>
+              <a:t>Sai Ganesh</a:t>
             </a:r>
           </a:p>
         </p:txBody>
@@ -11428,8 +11428,8 @@
         </p:nvSpPr>
         <p:spPr>
           <a:xfrm>
-            <a:off x="9692640" y="6931152"/>
-            <a:ext cx="7406640" cy="365760"/>
+            <a:off x="9692640" y="7196328"/>
+            <a:ext cx="7406640" cy="640080"/>
           </a:xfrm>
           <a:prstGeom prst="rect">
             <a:avLst/>
@@ -11446,11 +11446,11 @@
             <a:r>
               <a:rPr sz="1700" b="0" i="0">
                 <a:solidFill>
-                  <a:srgbClr val="B43A2E"/>
+                  <a:srgbClr val="55555A"/>
                 </a:solidFill>
                 <a:latin typeface="Calibri"/>
               </a:rPr>
-              <a:t>ROLE (fill in)</a:t>
+              <a:t>Market research and pitch presentation</a:t>
             </a:r>
           </a:p>
         </p:txBody>
@@ -11463,7 +11463,7 @@
         </p:nvSpPr>
         <p:spPr>
           <a:xfrm>
-            <a:off x="9692640" y="7507224"/>
+            <a:off x="9692640" y="7946136"/>
             <a:ext cx="7406640" cy="411480"/>
           </a:xfrm>
           <a:prstGeom prst="rect">
@@ -11479,13 +11479,13 @@
           <a:p>
             <a:pPr algn="l"/>
             <a:r>
-              <a:rPr sz="2200" b="1" i="0">
-                <a:solidFill>
-                  <a:srgbClr val="B43A2E"/>
+              <a:rPr sz="2400" b="1" i="0">
+                <a:solidFill>
+                  <a:srgbClr val="1D1D1F"/>
                 </a:solidFill>
                 <a:latin typeface="Calibri"/>
               </a:rPr>
-              <a:t>MEMBER 3 NAME (fill in)</a:t>
+              <a:t>Ishaan Chhabra</a:t>
             </a:r>
           </a:p>
         </p:txBody>
@@ -11498,8 +11498,8 @@
         </p:nvSpPr>
         <p:spPr>
           <a:xfrm>
-            <a:off x="9692640" y="7918704"/>
-            <a:ext cx="7406640" cy="365760"/>
+            <a:off x="9692640" y="8403336"/>
+            <a:ext cx="7406640" cy="640080"/>
           </a:xfrm>
           <a:prstGeom prst="rect">
             <a:avLst/>
@@ -11516,81 +11516,11 @@
             <a:r>
               <a:rPr sz="1700" b="0" i="0">
                 <a:solidFill>
-                  <a:srgbClr val="B43A2E"/>
+                  <a:srgbClr val="55555A"/>
                 </a:solidFill>
                 <a:latin typeface="Calibri"/>
               </a:rPr>
-              <a:t>ROLE (fill in)</a:t>
-            </a:r>
-          </a:p>
-        </p:txBody>
-      </p:sp>
-      <p:sp>
-        <p:nvSpPr>
-          <p:cNvPr id="100" name="Member 4"/>
-          <p:cNvSpPr txBox="1"/>
-          <p:nvPr/>
-        </p:nvSpPr>
-        <p:spPr>
-          <a:xfrm>
-            <a:off x="9692640" y="8494776"/>
-            <a:ext cx="7406640" cy="411480"/>
-          </a:xfrm>
-          <a:prstGeom prst="rect">
-            <a:avLst/>
-          </a:prstGeom>
-          <a:noFill/>
-        </p:spPr>
-        <p:txBody>
-          <a:bodyPr wrap="square" lIns="0" rIns="0" tIns="0" bIns="0" anchor="t">
-            <a:spAutoFit/>
-          </a:bodyPr>
-          <a:lstStyle/>
-          <a:p>
-            <a:pPr algn="l"/>
-            <a:r>
-              <a:rPr sz="2200" b="1" i="0">
-                <a:solidFill>
-                  <a:srgbClr val="B43A2E"/>
-                </a:solidFill>
-                <a:latin typeface="Calibri"/>
-              </a:rPr>
-              <a:t>MEMBER 4 NAME (fill in)</a:t>
-            </a:r>
-          </a:p>
-        </p:txBody>
-      </p:sp>
-      <p:sp>
-        <p:nvSpPr>
-          <p:cNvPr id="101" name="TextBox 100"/>
-          <p:cNvSpPr txBox="1"/>
-          <p:nvPr/>
-        </p:nvSpPr>
-        <p:spPr>
-          <a:xfrm>
-            <a:off x="9692640" y="8906255"/>
-            <a:ext cx="7406640" cy="365760"/>
-          </a:xfrm>
-          <a:prstGeom prst="rect">
-            <a:avLst/>
-          </a:prstGeom>
-          <a:noFill/>
-        </p:spPr>
-        <p:txBody>
-          <a:bodyPr wrap="square" lIns="0" rIns="0" tIns="0" bIns="0" anchor="t">
-            <a:spAutoFit/>
-          </a:bodyPr>
-          <a:lstStyle/>
-          <a:p>
-            <a:pPr algn="l"/>
-            <a:r>
-              <a:rPr sz="1700" b="0" i="0">
-                <a:solidFill>
-                  <a:srgbClr val="B43A2E"/>
-                </a:solidFill>
-                <a:latin typeface="Calibri"/>
-              </a:rPr>
-              <a:t>ROLE (fill in)</a:t>
+              <a:t>Testing, data checks and documentation</a:t>
             </a:r>
           </a:p>
         </p:txBody>

</xml_diff>

<commit_message>
Round 1 deck v3: live link and QR, why-Parity panel and sealed result on the solution slide
- Slide 3: fresh screenshot (price cards, "worth trading today? No."), LIVE PROTOTYPE
  badge with parity-gold-site.vercel.app, four differentiators, and the sealed-test
  result moved up from slide 7
- Slide 4: live link beside the code link
- Slide 6: paper trading item reflects the built daily update pipeline
- Slide 8: QR and link now open the live site (QR verified by decoding)

Co-Authored-By: Claude Opus 5.5 <noreply@anthropic.com>
Claude-Session: https://claude.ai/code/session_01SCrYvEnNEBd2cWGPuTq3si
</commit_message>
<xml_diff>
--- a/commodity/presentation/round1/Parity_SyntaxTerror_Round1.pptx
+++ b/commodity/presentation/round1/Parity_SyntaxTerror_Round1.pptx
@@ -929,7 +929,7 @@
           <a:lstStyle/>
           <a:p>
             <a:r>
-              <a:t>Parity is a working dashboard. It compares the four contracts fairly, raises an alert only when one strays far from fair price, backtests every rule after real costs on unseen data, and checks every trade against the contract calendar.</a:t>
+              <a:t>Parity is live at parity-gold-site.vercel.app. It compares the four contracts fairly, raises an alert only when a contract strays far from its fair price, backtests every rule after real costs, and checks every trade against the contract calendar. What sets it apart: 23 years of MCX data, eight years sealed and tested once, a fair price built off GOLDM, and the exchange's own delivery rules. Tested once on eight unseen years, the fair-price rule made money in all three sealed tests, but the edge is small, and we say so.</a:t>
             </a:r>
           </a:p>
         </p:txBody>
@@ -14199,7 +14199,9 @@
       </p:sp>
       <p:pic>
         <p:nvPicPr>
-          <p:cNvPr id="110" name="Dashboard screenshot" descr="dash-overview.png"/>
+          <p:cNvPr id="110" name="Dashboard screenshot" descr="dash-overview-v3.png">
+            <a:hlinkClick r:id="rId5"/>
+          </p:cNvPr>
           <p:cNvPicPr>
             <a:picLocks noChangeAspect="1"/>
           </p:cNvPicPr>
@@ -14213,8 +14215,8 @@
         </p:blipFill>
         <p:spPr>
           <a:xfrm>
-            <a:off x="914400" y="2880360"/>
-            <a:ext cx="9692640" cy="6057900"/>
+            <a:off x="914400" y="2788920"/>
+            <a:ext cx="9326880" cy="4453585"/>
           </a:xfrm>
           <a:prstGeom prst="rect">
             <a:avLst/>
@@ -14228,14 +14230,14 @@
       </p:pic>
       <p:sp>
         <p:nvSpPr>
-          <p:cNvPr id="111" name="Prototype badge"/>
+          <p:cNvPr id="111" name="Live badge"/>
           <p:cNvSpPr/>
           <p:nvPr/>
         </p:nvSpPr>
         <p:spPr>
           <a:xfrm>
-            <a:off x="914400" y="9098280"/>
-            <a:ext cx="3246120" cy="548640"/>
+            <a:off x="914400" y="7424927"/>
+            <a:ext cx="2743200" cy="548640"/>
           </a:xfrm>
           <a:prstGeom prst="roundRect">
             <a:avLst>
@@ -14280,8 +14282,8 @@
         </p:nvSpPr>
         <p:spPr>
           <a:xfrm>
-            <a:off x="914400" y="9098280"/>
-            <a:ext cx="3246120" cy="548640"/>
+            <a:off x="914400" y="7424927"/>
+            <a:ext cx="2743200" cy="548640"/>
           </a:xfrm>
           <a:prstGeom prst="rect">
             <a:avLst/>
@@ -14306,21 +14308,23 @@
                 </a:solidFill>
                 <a:latin typeface="Montserrat"/>
               </a:rPr>
-              <a:t>WORKING PROTOTYPE</a:t>
+              <a:t>LIVE PROTOTYPE</a:t>
             </a:r>
           </a:p>
         </p:txBody>
       </p:sp>
       <p:sp>
         <p:nvSpPr>
-          <p:cNvPr id="113" name="TextBox 112"/>
+          <p:cNvPr id="113" name="Live link">
+            <a:hlinkClick r:id="rId5"/>
+          </p:cNvPr>
           <p:cNvSpPr txBox="1"/>
           <p:nvPr/>
         </p:nvSpPr>
         <p:spPr>
           <a:xfrm>
-            <a:off x="4389120" y="9098280"/>
-            <a:ext cx="6217920" cy="548640"/>
+            <a:off x="3840480" y="7424927"/>
+            <a:ext cx="6400800" cy="548640"/>
           </a:xfrm>
           <a:prstGeom prst="rect">
             <a:avLst/>
@@ -14339,33 +14343,44 @@
               </a:spcAft>
             </a:pPr>
             <a:r>
-              <a:rPr sz="1700" b="0">
-                <a:solidFill>
-                  <a:srgbClr val="4A4A50"/>
+              <a:rPr sz="2100" b="1">
+                <a:solidFill>
+                  <a:srgbClr val="835A07"/>
                 </a:solidFill>
                 <a:latin typeface="Calibri"/>
               </a:rPr>
-              <a:t>8 pages, search and downloads, runs offline as one file</a:t>
+              <a:t>parity-gold-site.vercel.app</a:t>
             </a:r>
-          </a:p>
-        </p:txBody>
-      </p:sp>
-      <p:sp>
-        <p:nvSpPr>
-          <p:cNvPr id="114" name="Oval 113"/>
+            <a:r>
+              <a:rPr sz="1700" b="0">
+                <a:solidFill>
+                  <a:srgbClr val="4A4A50"/>
+                </a:solidFill>
+                <a:latin typeface="Calibri"/>
+              </a:rPr>
+              <a:t>   8 pages, open in any browser</a:t>
+            </a:r>
+          </a:p>
+        </p:txBody>
+      </p:sp>
+      <p:sp>
+        <p:nvSpPr>
+          <p:cNvPr id="114" name="Result"/>
           <p:cNvSpPr/>
           <p:nvPr/>
         </p:nvSpPr>
         <p:spPr>
           <a:xfrm>
-            <a:off x="11064240" y="2926079"/>
-            <a:ext cx="731520" cy="731520"/>
-          </a:xfrm>
-          <a:prstGeom prst="ellipse">
-            <a:avLst/>
+            <a:off x="914400" y="8229600"/>
+            <a:ext cx="9326880" cy="1508760"/>
+          </a:xfrm>
+          <a:prstGeom prst="roundRect">
+            <a:avLst>
+              <a:gd name="adj" fmla="val 5000"/>
+            </a:avLst>
           </a:prstGeom>
           <a:solidFill>
-            <a:srgbClr val="835A07"/>
+            <a:srgbClr val="FBF4E4"/>
           </a:solidFill>
           <a:ln>
             <a:noFill/>
@@ -14394,94 +14409,15 @@
           </a:p>
         </p:txBody>
       </p:sp>
-      <p:pic>
-        <p:nvPicPr>
-          <p:cNvPr id="115" name="Picture 114" descr="scale_w.png"/>
-          <p:cNvPicPr>
-            <a:picLocks noChangeAspect="1"/>
-          </p:cNvPicPr>
-          <p:nvPr/>
-        </p:nvPicPr>
-        <p:blipFill>
-          <a:blip r:embed="rId5"/>
-          <a:stretch>
-            <a:fillRect/>
-          </a:stretch>
-        </p:blipFill>
-        <p:spPr>
-          <a:xfrm>
-            <a:off x="11225174" y="3087014"/>
-            <a:ext cx="409651" cy="409651"/>
-          </a:xfrm>
-          <a:prstGeom prst="rect">
-            <a:avLst/>
-          </a:prstGeom>
-        </p:spPr>
-      </p:pic>
-      <p:sp>
-        <p:nvSpPr>
-          <p:cNvPr id="116" name="TextBox 115"/>
-          <p:cNvSpPr txBox="1"/>
-          <p:nvPr/>
-        </p:nvSpPr>
-        <p:spPr>
-          <a:xfrm>
-            <a:off x="12024360" y="2880360"/>
-            <a:ext cx="5349240" cy="1143000"/>
-          </a:xfrm>
-          <a:prstGeom prst="rect">
-            <a:avLst/>
-          </a:prstGeom>
-          <a:noFill/>
-        </p:spPr>
-        <p:txBody>
-          <a:bodyPr wrap="square" anchor="t" lIns="0" rIns="0" tIns="0" bIns="0">
-            <a:spAutoFit/>
-          </a:bodyPr>
-          <a:lstStyle/>
-          <a:p>
-            <a:pPr algn="l">
-              <a:spcAft>
-                <a:spcPts val="200"/>
-              </a:spcAft>
-            </a:pPr>
-            <a:r>
-              <a:rPr sz="2300" b="1">
-                <a:solidFill>
-                  <a:srgbClr val="1D1D1F"/>
-                </a:solidFill>
-                <a:latin typeface="Calibri"/>
-              </a:rPr>
-              <a:t>Fair comparison</a:t>
-            </a:r>
-          </a:p>
-          <a:p>
-            <a:pPr algn="l">
-              <a:spcAft>
-                <a:spcPts val="200"/>
-              </a:spcAft>
-            </a:pPr>
-            <a:r>
-              <a:rPr sz="1900" b="0">
-                <a:solidFill>
-                  <a:srgbClr val="4A4A50"/>
-                </a:solidFill>
-                <a:latin typeface="Calibri"/>
-              </a:rPr>
-              <a:t>All four contracts in ₹ per gram of pure gold</a:t>
-            </a:r>
-          </a:p>
-        </p:txBody>
-      </p:sp>
-      <p:sp>
-        <p:nvSpPr>
-          <p:cNvPr id="117" name="Oval 116"/>
+      <p:sp>
+        <p:nvSpPr>
+          <p:cNvPr id="115" name="Oval 114"/>
           <p:cNvSpPr/>
           <p:nvPr/>
         </p:nvSpPr>
         <p:spPr>
           <a:xfrm>
-            <a:off x="11064240" y="4133087"/>
+            <a:off x="1188720" y="8503920"/>
             <a:ext cx="731520" cy="731520"/>
           </a:xfrm>
           <a:prstGeom prst="ellipse">
@@ -14519,7 +14455,7 @@
       </p:sp>
       <p:pic>
         <p:nvPicPr>
-          <p:cNvPr id="118" name="Picture 117" descr="bell_w.png"/>
+          <p:cNvPr id="116" name="Picture 115" descr="flask_w.png"/>
           <p:cNvPicPr>
             <a:picLocks noChangeAspect="1"/>
           </p:cNvPicPr>
@@ -14533,7 +14469,7 @@
         </p:blipFill>
         <p:spPr>
           <a:xfrm>
-            <a:off x="11225174" y="4294022"/>
+            <a:off x="1349654" y="8664854"/>
             <a:ext cx="409651" cy="409651"/>
           </a:xfrm>
           <a:prstGeom prst="rect">
@@ -14543,14 +14479,14 @@
       </p:pic>
       <p:sp>
         <p:nvSpPr>
-          <p:cNvPr id="119" name="TextBox 118"/>
+          <p:cNvPr id="117" name="TextBox 116"/>
           <p:cNvSpPr txBox="1"/>
           <p:nvPr/>
         </p:nvSpPr>
         <p:spPr>
           <a:xfrm>
-            <a:off x="12024360" y="4087368"/>
-            <a:ext cx="5349240" cy="1143000"/>
+            <a:off x="2148840" y="8385048"/>
+            <a:ext cx="7909560" cy="1280160"/>
           </a:xfrm>
           <a:prstGeom prst="rect">
             <a:avLst/>
@@ -14565,47 +14501,86 @@
           <a:p>
             <a:pPr algn="l">
               <a:spcAft>
-                <a:spcPts val="200"/>
+                <a:spcPts val="400"/>
               </a:spcAft>
             </a:pPr>
             <a:r>
-              <a:rPr sz="2300" b="1">
+              <a:rPr sz="1800" b="1">
+                <a:solidFill>
+                  <a:srgbClr val="835A07"/>
+                </a:solidFill>
+                <a:latin typeface="Montserrat"/>
+              </a:rPr>
+              <a:t>TESTED ONCE ON 8 YEARS IT NEVER SAW</a:t>
+            </a:r>
+          </a:p>
+          <a:p>
+            <a:pPr algn="l">
+              <a:spcAft>
+                <a:spcPts val="400"/>
+              </a:spcAft>
+            </a:pPr>
+            <a:r>
+              <a:rPr sz="2000" b="0">
                 <a:solidFill>
                   <a:srgbClr val="1D1D1F"/>
                 </a:solidFill>
                 <a:latin typeface="Calibri"/>
               </a:rPr>
-              <a:t>Quiet alerts</a:t>
+              <a:t>The fair-price rule made money in all 3 sealed tests, after every cost. The edge is small, and we say so.</a:t>
             </a:r>
           </a:p>
+        </p:txBody>
+      </p:sp>
+      <p:sp>
+        <p:nvSpPr>
+          <p:cNvPr id="118" name="TextBox 117"/>
+          <p:cNvSpPr txBox="1"/>
+          <p:nvPr/>
+        </p:nvSpPr>
+        <p:spPr>
+          <a:xfrm>
+            <a:off x="10744200" y="2788920"/>
+            <a:ext cx="6583680" cy="365760"/>
+          </a:xfrm>
+          <a:prstGeom prst="rect">
+            <a:avLst/>
+          </a:prstGeom>
+          <a:noFill/>
+        </p:spPr>
+        <p:txBody>
+          <a:bodyPr wrap="square" anchor="t" lIns="0" rIns="0" tIns="0" bIns="0">
+            <a:spAutoFit/>
+          </a:bodyPr>
+          <a:lstStyle/>
           <a:p>
             <a:pPr algn="l">
               <a:spcAft>
-                <a:spcPts val="200"/>
+                <a:spcPts val="0"/>
               </a:spcAft>
             </a:pPr>
             <a:r>
-              <a:rPr sz="1900" b="0">
-                <a:solidFill>
-                  <a:srgbClr val="4A4A50"/>
-                </a:solidFill>
-                <a:latin typeface="Calibri"/>
+              <a:rPr sz="1800" b="1">
+                <a:solidFill>
+                  <a:srgbClr val="835A07"/>
+                </a:solidFill>
+                <a:latin typeface="Montserrat"/>
               </a:rPr>
-              <a:t>Speaks up only when a contract strays far from its fair price</a:t>
+              <a:t>WHAT IT DOES</a:t>
             </a:r>
           </a:p>
         </p:txBody>
       </p:sp>
       <p:sp>
         <p:nvSpPr>
-          <p:cNvPr id="120" name="Oval 119"/>
+          <p:cNvPr id="119" name="Oval 118"/>
           <p:cNvSpPr/>
           <p:nvPr/>
         </p:nvSpPr>
         <p:spPr>
           <a:xfrm>
-            <a:off x="11064240" y="5340096"/>
-            <a:ext cx="731520" cy="731520"/>
+            <a:off x="10744200" y="3246120"/>
+            <a:ext cx="566928" cy="566928"/>
           </a:xfrm>
           <a:prstGeom prst="ellipse">
             <a:avLst/>
@@ -14642,7 +14617,7 @@
       </p:sp>
       <p:pic>
         <p:nvPicPr>
-          <p:cNvPr id="121" name="Picture 120" descr="flask_w.png"/>
+          <p:cNvPr id="120" name="Picture 119" descr="scale_w.png"/>
           <p:cNvPicPr>
             <a:picLocks noChangeAspect="1"/>
           </p:cNvPicPr>
@@ -14656,8 +14631,8 @@
         </p:blipFill>
         <p:spPr>
           <a:xfrm>
-            <a:off x="11225174" y="5501030"/>
-            <a:ext cx="409651" cy="409651"/>
+            <a:off x="10868924" y="3370844"/>
+            <a:ext cx="317479" cy="317479"/>
           </a:xfrm>
           <a:prstGeom prst="rect">
             <a:avLst/>
@@ -14666,14 +14641,14 @@
       </p:pic>
       <p:sp>
         <p:nvSpPr>
-          <p:cNvPr id="122" name="TextBox 121"/>
+          <p:cNvPr id="121" name="TextBox 120"/>
           <p:cNvSpPr txBox="1"/>
           <p:nvPr/>
         </p:nvSpPr>
         <p:spPr>
           <a:xfrm>
-            <a:off x="12024360" y="5294376"/>
-            <a:ext cx="5349240" cy="1143000"/>
+            <a:off x="11521440" y="3246120"/>
+            <a:ext cx="5852160" cy="566928"/>
           </a:xfrm>
           <a:prstGeom prst="rect">
             <a:avLst/>
@@ -14681,54 +14656,47 @@
           <a:noFill/>
         </p:spPr>
         <p:txBody>
-          <a:bodyPr wrap="square" anchor="t" lIns="0" rIns="0" tIns="0" bIns="0">
+          <a:bodyPr wrap="square" anchor="ctr" lIns="0" rIns="0" tIns="0" bIns="0">
             <a:spAutoFit/>
           </a:bodyPr>
           <a:lstStyle/>
           <a:p>
             <a:pPr algn="l">
               <a:spcAft>
-                <a:spcPts val="200"/>
+                <a:spcPts val="0"/>
               </a:spcAft>
             </a:pPr>
             <a:r>
-              <a:rPr sz="2300" b="1">
+              <a:rPr sz="2100" b="1">
                 <a:solidFill>
                   <a:srgbClr val="1D1D1F"/>
                 </a:solidFill>
                 <a:latin typeface="Calibri"/>
               </a:rPr>
-              <a:t>Honest backtests</a:t>
+              <a:t>Fair comparison</a:t>
             </a:r>
-          </a:p>
-          <a:p>
-            <a:pPr algn="l">
-              <a:spcAft>
-                <a:spcPts val="200"/>
-              </a:spcAft>
-            </a:pPr>
             <a:r>
-              <a:rPr sz="1900" b="0">
+              <a:rPr sz="1800" b="0">
                 <a:solidFill>
                   <a:srgbClr val="4A4A50"/>
                 </a:solidFill>
                 <a:latin typeface="Calibri"/>
               </a:rPr>
-              <a:t>After every MCX fee and tax, on data the rules never saw</a:t>
+              <a:t>  all four in ₹ per pure gram</a:t>
             </a:r>
           </a:p>
         </p:txBody>
       </p:sp>
       <p:sp>
         <p:nvSpPr>
-          <p:cNvPr id="123" name="Oval 122"/>
+          <p:cNvPr id="122" name="Oval 121"/>
           <p:cNvSpPr/>
           <p:nvPr/>
         </p:nvSpPr>
         <p:spPr>
           <a:xfrm>
-            <a:off x="11064240" y="6547103"/>
-            <a:ext cx="731520" cy="731520"/>
+            <a:off x="10744200" y="3959352"/>
+            <a:ext cx="566928" cy="566928"/>
           </a:xfrm>
           <a:prstGeom prst="ellipse">
             <a:avLst/>
@@ -14765,7 +14733,7 @@
       </p:sp>
       <p:pic>
         <p:nvPicPr>
-          <p:cNvPr id="124" name="Picture 123" descr="calendar_w.png"/>
+          <p:cNvPr id="123" name="Picture 122" descr="bell_w.png"/>
           <p:cNvPicPr>
             <a:picLocks noChangeAspect="1"/>
           </p:cNvPicPr>
@@ -14779,8 +14747,8 @@
         </p:blipFill>
         <p:spPr>
           <a:xfrm>
-            <a:off x="11225174" y="6708038"/>
-            <a:ext cx="409651" cy="409651"/>
+            <a:off x="10868924" y="4084076"/>
+            <a:ext cx="317479" cy="317479"/>
           </a:xfrm>
           <a:prstGeom prst="rect">
             <a:avLst/>
@@ -14789,14 +14757,14 @@
       </p:pic>
       <p:sp>
         <p:nvSpPr>
-          <p:cNvPr id="125" name="TextBox 124"/>
+          <p:cNvPr id="124" name="TextBox 123"/>
           <p:cNvSpPr txBox="1"/>
           <p:nvPr/>
         </p:nvSpPr>
         <p:spPr>
           <a:xfrm>
-            <a:off x="12024360" y="6501383"/>
-            <a:ext cx="5349240" cy="1143000"/>
+            <a:off x="11521440" y="3959352"/>
+            <a:ext cx="5852160" cy="566928"/>
           </a:xfrm>
           <a:prstGeom prst="rect">
             <a:avLst/>
@@ -14804,62 +14772,53 @@
           <a:noFill/>
         </p:spPr>
         <p:txBody>
-          <a:bodyPr wrap="square" anchor="t" lIns="0" rIns="0" tIns="0" bIns="0">
+          <a:bodyPr wrap="square" anchor="ctr" lIns="0" rIns="0" tIns="0" bIns="0">
             <a:spAutoFit/>
           </a:bodyPr>
           <a:lstStyle/>
           <a:p>
             <a:pPr algn="l">
               <a:spcAft>
-                <a:spcPts val="200"/>
+                <a:spcPts val="0"/>
               </a:spcAft>
             </a:pPr>
             <a:r>
-              <a:rPr sz="2300" b="1">
+              <a:rPr sz="2100" b="1">
                 <a:solidFill>
                   <a:srgbClr val="1D1D1F"/>
                 </a:solidFill>
                 <a:latin typeface="Calibri"/>
               </a:rPr>
-              <a:t>Contract calendar</a:t>
+              <a:t>Quiet alerts</a:t>
             </a:r>
-          </a:p>
-          <a:p>
-            <a:pPr algn="l">
-              <a:spcAft>
-                <a:spcPts val="200"/>
-              </a:spcAft>
-            </a:pPr>
             <a:r>
-              <a:rPr sz="1900" b="0">
+              <a:rPr sz="1800" b="0">
                 <a:solidFill>
                   <a:srgbClr val="4A4A50"/>
                 </a:solidFill>
                 <a:latin typeface="Calibri"/>
               </a:rPr>
-              <a:t>Every trade checked against delivery dates</a:t>
+              <a:t>  only when a price strays far from fair</a:t>
             </a:r>
           </a:p>
         </p:txBody>
       </p:sp>
       <p:sp>
         <p:nvSpPr>
-          <p:cNvPr id="126" name="Unique value"/>
+          <p:cNvPr id="125" name="Oval 124"/>
           <p:cNvSpPr/>
           <p:nvPr/>
         </p:nvSpPr>
         <p:spPr>
           <a:xfrm>
-            <a:off x="11064240" y="7863840"/>
-            <a:ext cx="6309360" cy="1783080"/>
-          </a:xfrm>
-          <a:prstGeom prst="roundRect">
-            <a:avLst>
-              <a:gd name="adj" fmla="val 5000"/>
-            </a:avLst>
+            <a:off x="10744200" y="4672583"/>
+            <a:ext cx="566928" cy="566928"/>
+          </a:xfrm>
+          <a:prstGeom prst="ellipse">
+            <a:avLst/>
           </a:prstGeom>
           <a:solidFill>
-            <a:srgbClr val="FBF4E4"/>
+            <a:srgbClr val="835A07"/>
           </a:solidFill>
           <a:ln>
             <a:noFill/>
@@ -14888,6 +14847,30 @@
           </a:p>
         </p:txBody>
       </p:sp>
+      <p:pic>
+        <p:nvPicPr>
+          <p:cNvPr id="126" name="Picture 125" descr="flask_w.png"/>
+          <p:cNvPicPr>
+            <a:picLocks noChangeAspect="1"/>
+          </p:cNvPicPr>
+          <p:nvPr/>
+        </p:nvPicPr>
+        <p:blipFill>
+          <a:blip r:embed="rId6"/>
+          <a:stretch>
+            <a:fillRect/>
+          </a:stretch>
+        </p:blipFill>
+        <p:spPr>
+          <a:xfrm>
+            <a:off x="10868924" y="4797308"/>
+            <a:ext cx="317479" cy="317479"/>
+          </a:xfrm>
+          <a:prstGeom prst="rect">
+            <a:avLst/>
+          </a:prstGeom>
+        </p:spPr>
+      </p:pic>
       <p:sp>
         <p:nvSpPr>
           <p:cNvPr id="127" name="TextBox 126"/>
@@ -14896,8 +14879,220 @@
         </p:nvSpPr>
         <p:spPr>
           <a:xfrm>
-            <a:off x="11338560" y="8046720"/>
-            <a:ext cx="5852160" cy="1554480"/>
+            <a:off x="11521440" y="4672583"/>
+            <a:ext cx="5852160" cy="566928"/>
+          </a:xfrm>
+          <a:prstGeom prst="rect">
+            <a:avLst/>
+          </a:prstGeom>
+          <a:noFill/>
+        </p:spPr>
+        <p:txBody>
+          <a:bodyPr wrap="square" anchor="ctr" lIns="0" rIns="0" tIns="0" bIns="0">
+            <a:spAutoFit/>
+          </a:bodyPr>
+          <a:lstStyle/>
+          <a:p>
+            <a:pPr algn="l">
+              <a:spcAft>
+                <a:spcPts val="0"/>
+              </a:spcAft>
+            </a:pPr>
+            <a:r>
+              <a:rPr sz="2100" b="1">
+                <a:solidFill>
+                  <a:srgbClr val="1D1D1F"/>
+                </a:solidFill>
+                <a:latin typeface="Calibri"/>
+              </a:rPr>
+              <a:t>Honest backtests</a:t>
+            </a:r>
+            <a:r>
+              <a:rPr sz="1800" b="0">
+                <a:solidFill>
+                  <a:srgbClr val="4A4A50"/>
+                </a:solidFill>
+                <a:latin typeface="Calibri"/>
+              </a:rPr>
+              <a:t>  after every fee, tax and slippage</a:t>
+            </a:r>
+          </a:p>
+        </p:txBody>
+      </p:sp>
+      <p:sp>
+        <p:nvSpPr>
+          <p:cNvPr id="128" name="Oval 127"/>
+          <p:cNvSpPr/>
+          <p:nvPr/>
+        </p:nvSpPr>
+        <p:spPr>
+          <a:xfrm>
+            <a:off x="10744200" y="5385816"/>
+            <a:ext cx="566928" cy="566928"/>
+          </a:xfrm>
+          <a:prstGeom prst="ellipse">
+            <a:avLst/>
+          </a:prstGeom>
+          <a:solidFill>
+            <a:srgbClr val="835A07"/>
+          </a:solidFill>
+          <a:ln>
+            <a:noFill/>
+          </a:ln>
+          <a:effectLst/>
+        </p:spPr>
+        <p:style>
+          <a:lnRef idx="1">
+            <a:schemeClr val="accent1"/>
+          </a:lnRef>
+          <a:fillRef idx="3">
+            <a:schemeClr val="accent1"/>
+          </a:fillRef>
+          <a:effectRef idx="2">
+            <a:schemeClr val="accent1"/>
+          </a:effectRef>
+          <a:fontRef idx="minor">
+            <a:schemeClr val="lt1"/>
+          </a:fontRef>
+        </p:style>
+        <p:txBody>
+          <a:bodyPr rtlCol="0" anchor="ctr"/>
+          <a:lstStyle/>
+          <a:p>
+            <a:pPr algn="ctr"/>
+          </a:p>
+        </p:txBody>
+      </p:sp>
+      <p:pic>
+        <p:nvPicPr>
+          <p:cNvPr id="129" name="Picture 128" descr="calendar_w.png"/>
+          <p:cNvPicPr>
+            <a:picLocks noChangeAspect="1"/>
+          </p:cNvPicPr>
+          <p:nvPr/>
+        </p:nvPicPr>
+        <p:blipFill>
+          <a:blip r:embed="rId9"/>
+          <a:stretch>
+            <a:fillRect/>
+          </a:stretch>
+        </p:blipFill>
+        <p:spPr>
+          <a:xfrm>
+            <a:off x="10868924" y="5510540"/>
+            <a:ext cx="317479" cy="317479"/>
+          </a:xfrm>
+          <a:prstGeom prst="rect">
+            <a:avLst/>
+          </a:prstGeom>
+        </p:spPr>
+      </p:pic>
+      <p:sp>
+        <p:nvSpPr>
+          <p:cNvPr id="130" name="TextBox 129"/>
+          <p:cNvSpPr txBox="1"/>
+          <p:nvPr/>
+        </p:nvSpPr>
+        <p:spPr>
+          <a:xfrm>
+            <a:off x="11521440" y="5385816"/>
+            <a:ext cx="5852160" cy="566928"/>
+          </a:xfrm>
+          <a:prstGeom prst="rect">
+            <a:avLst/>
+          </a:prstGeom>
+          <a:noFill/>
+        </p:spPr>
+        <p:txBody>
+          <a:bodyPr wrap="square" anchor="ctr" lIns="0" rIns="0" tIns="0" bIns="0">
+            <a:spAutoFit/>
+          </a:bodyPr>
+          <a:lstStyle/>
+          <a:p>
+            <a:pPr algn="l">
+              <a:spcAft>
+                <a:spcPts val="0"/>
+              </a:spcAft>
+            </a:pPr>
+            <a:r>
+              <a:rPr sz="2100" b="1">
+                <a:solidFill>
+                  <a:srgbClr val="1D1D1F"/>
+                </a:solidFill>
+                <a:latin typeface="Calibri"/>
+              </a:rPr>
+              <a:t>Contract calendar</a:t>
+            </a:r>
+            <a:r>
+              <a:rPr sz="1800" b="0">
+                <a:solidFill>
+                  <a:srgbClr val="4A4A50"/>
+                </a:solidFill>
+                <a:latin typeface="Calibri"/>
+              </a:rPr>
+              <a:t>  every trade vs delivery dates</a:t>
+            </a:r>
+          </a:p>
+        </p:txBody>
+      </p:sp>
+      <p:sp>
+        <p:nvSpPr>
+          <p:cNvPr id="131" name="Why Parity"/>
+          <p:cNvSpPr/>
+          <p:nvPr/>
+        </p:nvSpPr>
+        <p:spPr>
+          <a:xfrm>
+            <a:off x="10744200" y="6263640"/>
+            <a:ext cx="6629400" cy="3474720"/>
+          </a:xfrm>
+          <a:prstGeom prst="roundRect">
+            <a:avLst>
+              <a:gd name="adj" fmla="val 5000"/>
+            </a:avLst>
+          </a:prstGeom>
+          <a:solidFill>
+            <a:srgbClr val="FFFFFF"/>
+          </a:solidFill>
+          <a:ln w="19050">
+            <a:solidFill>
+              <a:srgbClr val="DDD6C8"/>
+            </a:solidFill>
+          </a:ln>
+          <a:effectLst/>
+        </p:spPr>
+        <p:style>
+          <a:lnRef idx="1">
+            <a:schemeClr val="accent1"/>
+          </a:lnRef>
+          <a:fillRef idx="3">
+            <a:schemeClr val="accent1"/>
+          </a:fillRef>
+          <a:effectRef idx="2">
+            <a:schemeClr val="accent1"/>
+          </a:effectRef>
+          <a:fontRef idx="minor">
+            <a:schemeClr val="lt1"/>
+          </a:fontRef>
+        </p:style>
+        <p:txBody>
+          <a:bodyPr rtlCol="0" anchor="ctr"/>
+          <a:lstStyle/>
+          <a:p>
+            <a:pPr algn="ctr"/>
+          </a:p>
+        </p:txBody>
+      </p:sp>
+      <p:sp>
+        <p:nvSpPr>
+          <p:cNvPr id="132" name="TextBox 131"/>
+          <p:cNvSpPr txBox="1"/>
+          <p:nvPr/>
+        </p:nvSpPr>
+        <p:spPr>
+          <a:xfrm>
+            <a:off x="11018520" y="6419088"/>
+            <a:ext cx="6217920" cy="365760"/>
           </a:xfrm>
           <a:prstGeom prst="rect">
             <a:avLst/>
@@ -14912,7 +15107,7 @@
           <a:p>
             <a:pPr algn="l">
               <a:spcAft>
-                <a:spcPts val="400"/>
+                <a:spcPts val="0"/>
               </a:spcAft>
             </a:pPr>
             <a:r>
@@ -14922,23 +15117,383 @@
                 </a:solidFill>
                 <a:latin typeface="Montserrat"/>
               </a:rPr>
-              <a:t>UNIQUE VALUE</a:t>
+              <a:t>WHY PARITY, NOT A SNAPSHOT</a:t>
             </a:r>
           </a:p>
+        </p:txBody>
+      </p:sp>
+      <p:sp>
+        <p:nvSpPr>
+          <p:cNvPr id="133" name="TextBox 132"/>
+          <p:cNvSpPr txBox="1"/>
+          <p:nvPr/>
+        </p:nvSpPr>
+        <p:spPr>
+          <a:xfrm>
+            <a:off x="11018520" y="6858000"/>
+            <a:ext cx="548640" cy="640080"/>
+          </a:xfrm>
+          <a:prstGeom prst="rect">
+            <a:avLst/>
+          </a:prstGeom>
+          <a:noFill/>
+        </p:spPr>
+        <p:txBody>
+          <a:bodyPr wrap="square" anchor="t" lIns="0" rIns="0" tIns="0" bIns="0">
+            <a:spAutoFit/>
+          </a:bodyPr>
+          <a:lstStyle/>
           <a:p>
             <a:pPr algn="l">
               <a:spcAft>
-                <a:spcPts val="400"/>
+                <a:spcPts val="0"/>
               </a:spcAft>
             </a:pPr>
             <a:r>
-              <a:rPr sz="2000" b="0">
+              <a:rPr sz="2000" b="1">
+                <a:solidFill>
+                  <a:srgbClr val="835A07"/>
+                </a:solidFill>
+                <a:latin typeface="Montserrat"/>
+              </a:rPr>
+              <a:t>01</a:t>
+            </a:r>
+          </a:p>
+        </p:txBody>
+      </p:sp>
+      <p:sp>
+        <p:nvSpPr>
+          <p:cNvPr id="134" name="TextBox 133"/>
+          <p:cNvSpPr txBox="1"/>
+          <p:nvPr/>
+        </p:nvSpPr>
+        <p:spPr>
+          <a:xfrm>
+            <a:off x="11567160" y="6858000"/>
+            <a:ext cx="5669280" cy="685800"/>
+          </a:xfrm>
+          <a:prstGeom prst="rect">
+            <a:avLst/>
+          </a:prstGeom>
+          <a:noFill/>
+        </p:spPr>
+        <p:txBody>
+          <a:bodyPr wrap="square" anchor="t" lIns="0" rIns="0" tIns="0" bIns="0">
+            <a:spAutoFit/>
+          </a:bodyPr>
+          <a:lstStyle/>
+          <a:p>
+            <a:pPr algn="l">
+              <a:spcAft>
+                <a:spcPts val="0"/>
+              </a:spcAft>
+            </a:pPr>
+            <a:r>
+              <a:rPr sz="2000" b="1">
                 <a:solidFill>
                   <a:srgbClr val="1D1D1F"/>
                 </a:solidFill>
                 <a:latin typeface="Calibri"/>
               </a:rPr>
-              <a:t>Honest by design: rules locked in Git before every test, 3 sealed tests run once, and losses shown too.</a:t>
+              <a:t>23 years of MCX data</a:t>
+            </a:r>
+          </a:p>
+          <a:p>
+            <a:pPr algn="l">
+              <a:spcAft>
+                <a:spcPts val="0"/>
+              </a:spcAft>
+            </a:pPr>
+            <a:r>
+              <a:rPr sz="1600" b="0">
+                <a:solidFill>
+                  <a:srgbClr val="4A4A50"/>
+                </a:solidFill>
+                <a:latin typeface="Calibri"/>
+              </a:rPr>
+              <a:t>710 contracts, 2003–2026, every row checked</a:t>
+            </a:r>
+          </a:p>
+        </p:txBody>
+      </p:sp>
+      <p:sp>
+        <p:nvSpPr>
+          <p:cNvPr id="135" name="TextBox 134"/>
+          <p:cNvSpPr txBox="1"/>
+          <p:nvPr/>
+        </p:nvSpPr>
+        <p:spPr>
+          <a:xfrm>
+            <a:off x="11018520" y="7562088"/>
+            <a:ext cx="548640" cy="640080"/>
+          </a:xfrm>
+          <a:prstGeom prst="rect">
+            <a:avLst/>
+          </a:prstGeom>
+          <a:noFill/>
+        </p:spPr>
+        <p:txBody>
+          <a:bodyPr wrap="square" anchor="t" lIns="0" rIns="0" tIns="0" bIns="0">
+            <a:spAutoFit/>
+          </a:bodyPr>
+          <a:lstStyle/>
+          <a:p>
+            <a:pPr algn="l">
+              <a:spcAft>
+                <a:spcPts val="0"/>
+              </a:spcAft>
+            </a:pPr>
+            <a:r>
+              <a:rPr sz="2000" b="1">
+                <a:solidFill>
+                  <a:srgbClr val="835A07"/>
+                </a:solidFill>
+                <a:latin typeface="Montserrat"/>
+              </a:rPr>
+              <a:t>02</a:t>
+            </a:r>
+          </a:p>
+        </p:txBody>
+      </p:sp>
+      <p:sp>
+        <p:nvSpPr>
+          <p:cNvPr id="136" name="TextBox 135"/>
+          <p:cNvSpPr txBox="1"/>
+          <p:nvPr/>
+        </p:nvSpPr>
+        <p:spPr>
+          <a:xfrm>
+            <a:off x="11567160" y="7562088"/>
+            <a:ext cx="5669280" cy="685800"/>
+          </a:xfrm>
+          <a:prstGeom prst="rect">
+            <a:avLst/>
+          </a:prstGeom>
+          <a:noFill/>
+        </p:spPr>
+        <p:txBody>
+          <a:bodyPr wrap="square" anchor="t" lIns="0" rIns="0" tIns="0" bIns="0">
+            <a:spAutoFit/>
+          </a:bodyPr>
+          <a:lstStyle/>
+          <a:p>
+            <a:pPr algn="l">
+              <a:spcAft>
+                <a:spcPts val="0"/>
+              </a:spcAft>
+            </a:pPr>
+            <a:r>
+              <a:rPr sz="2000" b="1">
+                <a:solidFill>
+                  <a:srgbClr val="1D1D1F"/>
+                </a:solidFill>
+                <a:latin typeface="Calibri"/>
+              </a:rPr>
+              <a:t>8 sealed years, tested once</a:t>
+            </a:r>
+          </a:p>
+          <a:p>
+            <a:pPr algn="l">
+              <a:spcAft>
+                <a:spcPts val="0"/>
+              </a:spcAft>
+            </a:pPr>
+            <a:r>
+              <a:rPr sz="1600" b="0">
+                <a:solidFill>
+                  <a:srgbClr val="4A4A50"/>
+                </a:solidFill>
+                <a:latin typeface="Calibri"/>
+              </a:rPr>
+              <a:t>rules frozen in Git before the data was opened</a:t>
+            </a:r>
+          </a:p>
+        </p:txBody>
+      </p:sp>
+      <p:sp>
+        <p:nvSpPr>
+          <p:cNvPr id="137" name="TextBox 136"/>
+          <p:cNvSpPr txBox="1"/>
+          <p:nvPr/>
+        </p:nvSpPr>
+        <p:spPr>
+          <a:xfrm>
+            <a:off x="11018520" y="8266175"/>
+            <a:ext cx="548640" cy="640080"/>
+          </a:xfrm>
+          <a:prstGeom prst="rect">
+            <a:avLst/>
+          </a:prstGeom>
+          <a:noFill/>
+        </p:spPr>
+        <p:txBody>
+          <a:bodyPr wrap="square" anchor="t" lIns="0" rIns="0" tIns="0" bIns="0">
+            <a:spAutoFit/>
+          </a:bodyPr>
+          <a:lstStyle/>
+          <a:p>
+            <a:pPr algn="l">
+              <a:spcAft>
+                <a:spcPts val="0"/>
+              </a:spcAft>
+            </a:pPr>
+            <a:r>
+              <a:rPr sz="2000" b="1">
+                <a:solidFill>
+                  <a:srgbClr val="835A07"/>
+                </a:solidFill>
+                <a:latin typeface="Montserrat"/>
+              </a:rPr>
+              <a:t>03</a:t>
+            </a:r>
+          </a:p>
+        </p:txBody>
+      </p:sp>
+      <p:sp>
+        <p:nvSpPr>
+          <p:cNvPr id="138" name="TextBox 137"/>
+          <p:cNvSpPr txBox="1"/>
+          <p:nvPr/>
+        </p:nvSpPr>
+        <p:spPr>
+          <a:xfrm>
+            <a:off x="11567160" y="8266175"/>
+            <a:ext cx="5669280" cy="685800"/>
+          </a:xfrm>
+          <a:prstGeom prst="rect">
+            <a:avLst/>
+          </a:prstGeom>
+          <a:noFill/>
+        </p:spPr>
+        <p:txBody>
+          <a:bodyPr wrap="square" anchor="t" lIns="0" rIns="0" tIns="0" bIns="0">
+            <a:spAutoFit/>
+          </a:bodyPr>
+          <a:lstStyle/>
+          <a:p>
+            <a:pPr algn="l">
+              <a:spcAft>
+                <a:spcPts val="0"/>
+              </a:spcAft>
+            </a:pPr>
+            <a:r>
+              <a:rPr sz="2000" b="1">
+                <a:solidFill>
+                  <a:srgbClr val="1D1D1F"/>
+                </a:solidFill>
+                <a:latin typeface="Calibri"/>
+              </a:rPr>
+              <a:t>Fair price off GOLDM</a:t>
+            </a:r>
+          </a:p>
+          <a:p>
+            <a:pPr algn="l">
+              <a:spcAft>
+                <a:spcPts val="0"/>
+              </a:spcAft>
+            </a:pPr>
+            <a:r>
+              <a:rPr sz="1600" b="0">
+                <a:solidFill>
+                  <a:srgbClr val="4A4A50"/>
+                </a:solidFill>
+                <a:latin typeface="Calibri"/>
+              </a:rPr>
+              <a:t>the contract with 20–60× the volume, not thin pairs</a:t>
+            </a:r>
+          </a:p>
+        </p:txBody>
+      </p:sp>
+      <p:sp>
+        <p:nvSpPr>
+          <p:cNvPr id="139" name="TextBox 138"/>
+          <p:cNvSpPr txBox="1"/>
+          <p:nvPr/>
+        </p:nvSpPr>
+        <p:spPr>
+          <a:xfrm>
+            <a:off x="11018520" y="8970264"/>
+            <a:ext cx="548640" cy="640080"/>
+          </a:xfrm>
+          <a:prstGeom prst="rect">
+            <a:avLst/>
+          </a:prstGeom>
+          <a:noFill/>
+        </p:spPr>
+        <p:txBody>
+          <a:bodyPr wrap="square" anchor="t" lIns="0" rIns="0" tIns="0" bIns="0">
+            <a:spAutoFit/>
+          </a:bodyPr>
+          <a:lstStyle/>
+          <a:p>
+            <a:pPr algn="l">
+              <a:spcAft>
+                <a:spcPts val="0"/>
+              </a:spcAft>
+            </a:pPr>
+            <a:r>
+              <a:rPr sz="2000" b="1">
+                <a:solidFill>
+                  <a:srgbClr val="835A07"/>
+                </a:solidFill>
+                <a:latin typeface="Montserrat"/>
+              </a:rPr>
+              <a:t>04</a:t>
+            </a:r>
+          </a:p>
+        </p:txBody>
+      </p:sp>
+      <p:sp>
+        <p:nvSpPr>
+          <p:cNvPr id="140" name="TextBox 139"/>
+          <p:cNvSpPr txBox="1"/>
+          <p:nvPr/>
+        </p:nvSpPr>
+        <p:spPr>
+          <a:xfrm>
+            <a:off x="11567160" y="8970264"/>
+            <a:ext cx="5669280" cy="685800"/>
+          </a:xfrm>
+          <a:prstGeom prst="rect">
+            <a:avLst/>
+          </a:prstGeom>
+          <a:noFill/>
+        </p:spPr>
+        <p:txBody>
+          <a:bodyPr wrap="square" anchor="t" lIns="0" rIns="0" tIns="0" bIns="0">
+            <a:spAutoFit/>
+          </a:bodyPr>
+          <a:lstStyle/>
+          <a:p>
+            <a:pPr algn="l">
+              <a:spcAft>
+                <a:spcPts val="0"/>
+              </a:spcAft>
+            </a:pPr>
+            <a:r>
+              <a:rPr sz="2000" b="1">
+                <a:solidFill>
+                  <a:srgbClr val="1D1D1F"/>
+                </a:solidFill>
+                <a:latin typeface="Calibri"/>
+              </a:rPr>
+              <a:t>MCX's own rules</a:t>
+            </a:r>
+          </a:p>
+          <a:p>
+            <a:pPr algn="l">
+              <a:spcAft>
+                <a:spcPts val="0"/>
+              </a:spcAft>
+            </a:pPr>
+            <a:r>
+              <a:rPr sz="1600" b="0">
+                <a:solidFill>
+                  <a:srgbClr val="4A4A50"/>
+                </a:solidFill>
+                <a:latin typeface="Calibri"/>
+              </a:rPr>
+              <a:t>every trade checked against the delivery period</a:t>
             </a:r>
           </a:p>
         </p:txBody>
@@ -17252,7 +17807,9 @@
       </p:sp>
       <p:sp>
         <p:nvSpPr>
-          <p:cNvPr id="172" name="TextBox 171"/>
+          <p:cNvPr id="172" name="TextBox 171">
+            <a:hlinkClick r:id="rId15"/>
+          </p:cNvPr>
           <p:cNvSpPr txBox="1"/>
           <p:nvPr/>
         </p:nvSpPr>
@@ -17284,7 +17841,25 @@
                 </a:solidFill>
                 <a:latin typeface="Calibri"/>
               </a:rPr>
-              <a:t>Code: github.com/nikhilkumar-dev0310/HACKINHILLS-SYNTAXTERROR-TAN-</a:t>
+              <a:t>Live: </a:t>
+            </a:r>
+            <a:r>
+              <a:rPr sz="1600" b="1">
+                <a:solidFill>
+                  <a:srgbClr val="835A07"/>
+                </a:solidFill>
+                <a:latin typeface="Calibri"/>
+              </a:rPr>
+              <a:t>parity-gold-site.vercel.app</a:t>
+            </a:r>
+            <a:r>
+              <a:rPr sz="1600" b="0">
+                <a:solidFill>
+                  <a:srgbClr val="4A4A50"/>
+                </a:solidFill>
+                <a:latin typeface="Calibri"/>
+              </a:rPr>
+              <a:t>     Code: github.com/nikhilkumar-dev0310/HACKINHILLS-SYNTAXTERROR-TAN-</a:t>
             </a:r>
           </a:p>
         </p:txBody>
@@ -18876,7 +19451,7 @@
                 </a:solidFill>
                 <a:latin typeface="Calibri"/>
               </a:rPr>
-              <a:t>Run the fair-price rule every day on new MCX files, before any real money</a:t>
+              <a:t>Daily MCX update pipeline is built; next, a day-by-day paper record of the fair-price rule</a:t>
             </a:r>
           </a:p>
         </p:txBody>
@@ -21203,7 +21778,9 @@
       </p:sp>
       <p:pic>
         <p:nvPicPr>
-          <p:cNvPr id="163" name="Repository QR" descr="qr.png"/>
+          <p:cNvPr id="163" name="Live site QR" descr="qr-site.png">
+            <a:hlinkClick r:id="rId7"/>
+          </p:cNvPr>
           <p:cNvPicPr>
             <a:picLocks noChangeAspect="1"/>
           </p:cNvPicPr>
@@ -21227,14 +21804,16 @@
       </p:pic>
       <p:sp>
         <p:nvSpPr>
-          <p:cNvPr id="164" name="TextBox 163"/>
+          <p:cNvPr id="164" name="Live link">
+            <a:hlinkClick r:id="rId7"/>
+          </p:cNvPr>
           <p:cNvSpPr txBox="1"/>
           <p:nvPr/>
         </p:nvSpPr>
         <p:spPr>
           <a:xfrm>
-            <a:off x="14264640" y="9509760"/>
-            <a:ext cx="3200400" cy="365760"/>
+            <a:off x="914400" y="8092440"/>
+            <a:ext cx="16459200" cy="457200"/>
           </a:xfrm>
           <a:prstGeom prst="rect">
             <a:avLst/>
@@ -21247,6 +21826,54 @@
           </a:bodyPr>
           <a:lstStyle/>
           <a:p>
+            <a:pPr algn="ctr">
+              <a:spcAft>
+                <a:spcPts val="0"/>
+              </a:spcAft>
+            </a:pPr>
+            <a:r>
+              <a:rPr sz="2400" b="0">
+                <a:solidFill>
+                  <a:srgbClr val="4A4A50"/>
+                </a:solidFill>
+                <a:latin typeface="Calibri"/>
+              </a:rPr>
+              <a:t>Try it live: </a:t>
+            </a:r>
+            <a:r>
+              <a:rPr sz="2400" b="1">
+                <a:solidFill>
+                  <a:srgbClr val="835A07"/>
+                </a:solidFill>
+                <a:latin typeface="Calibri"/>
+              </a:rPr>
+              <a:t>parity-gold-site.vercel.app</a:t>
+            </a:r>
+          </a:p>
+        </p:txBody>
+      </p:sp>
+      <p:sp>
+        <p:nvSpPr>
+          <p:cNvPr id="165" name="TextBox 164"/>
+          <p:cNvSpPr txBox="1"/>
+          <p:nvPr/>
+        </p:nvSpPr>
+        <p:spPr>
+          <a:xfrm>
+            <a:off x="13350240" y="9509760"/>
+            <a:ext cx="4114800" cy="365760"/>
+          </a:xfrm>
+          <a:prstGeom prst="rect">
+            <a:avLst/>
+          </a:prstGeom>
+          <a:noFill/>
+        </p:spPr>
+        <p:txBody>
+          <a:bodyPr wrap="square" anchor="t" lIns="0" rIns="0" tIns="0" bIns="0">
+            <a:spAutoFit/>
+          </a:bodyPr>
+          <a:lstStyle/>
+          <a:p>
             <a:pPr algn="r">
               <a:spcAft>
                 <a:spcPts val="0"/>
@@ -21259,7 +21886,7 @@
                 </a:solidFill>
                 <a:latin typeface="Calibri"/>
               </a:rPr>
-              <a:t>Code on GitHub</a:t>
+              <a:t>Scan for the live site</a:t>
             </a:r>
           </a:p>
         </p:txBody>

</xml_diff>

<commit_message>
Deck: contract and row counts read from data.json (711 contracts, 55,505 rows)
Co-Authored-By: Claude Opus 5.5 <noreply@anthropic.com>
Claude-Session: https://claude.ai/code/session_01SCrYvEnNEBd2cWGPuTq3si
</commit_message>
<xml_diff>
--- a/commodity/presentation/round1/Parity_SyntaxTerror_Round1.pptx
+++ b/commodity/presentation/round1/Parity_SyntaxTerror_Round1.pptx
@@ -751,7 +751,7 @@
           <a:lstStyle/>
           <a:p>
             <a:r>
-              <a:t>We are SYNTAX TERROR (TAN). Our project, Parity, answers Problem 03 with a working prototype built on 710 official MCX gold contracts. It is live at parity-gold-site.vercel.app and updates itself every trading day.</a:t>
+              <a:t>We are SYNTAX TERROR (TAN). Our project, Parity, answers Problem 03 with a working prototype built on 711 official MCX gold contracts. It is live at parity-gold-site.vercel.app and updates itself every trading day.</a:t>
             </a:r>
           </a:p>
         </p:txBody>
@@ -11429,7 +11429,7 @@
       </p:sp>
       <p:sp>
         <p:nvSpPr>
-          <p:cNvPr id="97" name="710 contracts"/>
+          <p:cNvPr id="97" name="711 contracts"/>
           <p:cNvSpPr/>
           <p:nvPr/>
         </p:nvSpPr>
@@ -11531,7 +11531,7 @@
                 </a:solidFill>
                 <a:latin typeface="Calibri"/>
               </a:rPr>
-              <a:t>710 contracts</a:t>
+              <a:t>711 contracts</a:t>
             </a:r>
           </a:p>
         </p:txBody>
@@ -15356,7 +15356,7 @@
                 </a:solidFill>
                 <a:latin typeface="Calibri"/>
               </a:rPr>
-              <a:t>710 contracts since 2003; each new day fetched and checked</a:t>
+              <a:t>711 contracts since 2003; each new day fetched and checked</a:t>
             </a:r>
           </a:p>
         </p:txBody>
@@ -21409,7 +21409,7 @@
                 </a:solidFill>
                 <a:latin typeface="Montserrat"/>
               </a:rPr>
-              <a:t>710</a:t>
+              <a:t>711</a:t>
             </a:r>
           </a:p>
         </p:txBody>
@@ -21487,7 +21487,7 @@
                 </a:solidFill>
                 <a:latin typeface="Montserrat"/>
               </a:rPr>
-              <a:t>55,457</a:t>
+              <a:t>55,505</a:t>
             </a:r>
           </a:p>
         </p:txBody>

</xml_diff>